<commit_message>
Fix deck layout issues found in visual QA
Left-align titles and keep them clear of the part tracker, give the slide 2
check marker room, even out spacing on slides 3, 5, 6 and 7, align the source
line with the footer, and make the appendix one-pager full-slide so it is
legible. Add a PDF export of the deck.

Co-Authored-By: Claude Opus 5.5 <noreply@anthropic.com>
Claude-Session: https://claude.ai/code/session_016BcxbKvza49HtU4kNVhGJw
</commit_message>
<xml_diff>
--- a/summit/bin-blocking-flow/deck/bin-blocking-summit-deck.pptx
+++ b/summit/bin-blocking-flow/deck/bin-blocking-summit-deck.pptx
@@ -114,26 +114,26 @@
   <p:extLst>
     <p:ext uri="{521415D9-36F7-43E2-AB2F-B90AF26B5E84}">
       <p14:sectionLst xmlns:p14="http://schemas.microsoft.com/office/powerpoint/2010/main">
-        <p14:section name="Opening" id="{814cad02-132a-97b5-7703-e205751b805a}">
+        <p14:section name="Opening" id="{2fb3ba5c-4680-465a-79e9-c754c0300104}">
           <p14:sldIdLst>
             <p14:sldId id="256"/>
             <p14:sldId id="257"/>
           </p14:sldIdLst>
         </p14:section>
-        <p14:section name="How it works" id="{b299cf5d-0b0a-319e-47cf-0192938d699c}">
+        <p14:section name="How it works" id="{d4b6d9ed-ea8b-bee7-5b9c-bcfe781430fb}">
           <p14:sldIdLst>
             <p14:sldId id="258"/>
             <p14:sldId id="259"/>
             <p14:sldId id="260"/>
           </p14:sldIdLst>
         </p14:section>
-        <p14:section name="Lessons" id="{63e1afd0-0d0a-eaa6-49c1-56879c1a5123}">
+        <p14:section name="Lessons" id="{884653ae-8e60-45e5-2c8e-4847da5de74e}">
           <p14:sldIdLst>
             <p14:sldId id="261"/>
             <p14:sldId id="262"/>
           </p14:sldIdLst>
         </p14:section>
-        <p14:section name="Appendix" id="{942b348b-3ab3-a960-68af-36e9c8e02464}">
+        <p14:section name="Appendix" id="{812c889d-7cf4-c48b-0464-8d36e0f3be58}">
           <p14:sldIdLst>
             <p14:sldId id="263"/>
           </p14:sldIdLst>
@@ -1176,7 +1176,7 @@
           <a:p>
             <a:r>
               <a:rPr lang="en-US" dirty="0"/>
-              <a:t>Backup slide. Use it as a handout or for Q&amp;A; it is too dense to present from.</a:t>
+              <a:t>Appendix: the whole process on one page. Backup for Q&amp;A, and print the PDF version as a handout; it is too dense to present from.</a:t>
             </a:r>
             <a:endParaRPr lang="en-US" dirty="0"/>
           </a:p>
@@ -1282,6 +1282,38 @@
 
 <file path=ppt/slideLayouts/slideLayout3.xml><?xml version="1.0" encoding="utf-8"?>
 <p:sldLayout xmlns:a="http://schemas.openxmlformats.org/drawingml/2006/main" xmlns:r="http://schemas.openxmlformats.org/officeDocument/2006/relationships" xmlns:p="http://schemas.openxmlformats.org/presentationml/2006/main" preserve="1">
+  <p:cSld name="BLANK">
+    <p:bg>
+      <p:bgPr>
+        <a:solidFill>
+          <a:schemeClr val="bg1"/>
+        </a:solidFill>
+      </p:bgPr>
+    </p:bg>
+    <p:spTree>
+      <p:nvGrpSpPr>
+        <p:cNvPr id="1" name=""/>
+        <p:cNvGrpSpPr/>
+        <p:nvPr/>
+      </p:nvGrpSpPr>
+      <p:grpSpPr>
+        <a:xfrm>
+          <a:off x="0" y="0"/>
+          <a:ext cx="0" cy="0"/>
+          <a:chOff x="0" y="0"/>
+          <a:chExt cx="0" cy="0"/>
+        </a:xfrm>
+      </p:grpSpPr>
+    </p:spTree>
+  </p:cSld>
+  <p:clrMapOvr>
+    <a:masterClrMapping/>
+  </p:clrMapOvr>
+</p:sldLayout>
+</file>
+
+<file path=ppt/slideLayouts/slideLayout4.xml><?xml version="1.0" encoding="utf-8"?>
+<p:sldLayout xmlns:a="http://schemas.openxmlformats.org/drawingml/2006/main" xmlns:r="http://schemas.openxmlformats.org/officeDocument/2006/relationships" xmlns:p="http://schemas.openxmlformats.org/presentationml/2006/main" preserve="1">
   <p:cSld name="CONTENT">
     <p:bg>
       <p:bgPr>
@@ -1312,7 +1344,7 @@
         </p:nvSpPr>
         <p:spPr>
           <a:xfrm>
-            <a:off x="6583680" y="6400800"/>
+            <a:off x="6583680" y="6309360"/>
             <a:ext cx="4572000" cy="274320"/>
           </a:xfrm>
           <a:prstGeom prst="rect">
@@ -1351,7 +1383,7 @@
         <p:spPr>
           <a:xfrm>
             <a:off x="548640" y="384048"/>
-            <a:ext cx="7315200" cy="868680"/>
+            <a:ext cx="7040880" cy="868680"/>
           </a:xfrm>
           <a:prstGeom prst="rect">
             <a:avLst/>
@@ -1394,7 +1426,7 @@
         </p:nvSpPr>
         <p:spPr>
           <a:xfrm>
-            <a:off x="11274552" y="6400800"/>
+            <a:off x="11274552" y="6309360"/>
             <a:ext cx="365760" cy="274320"/>
           </a:xfrm>
           <a:prstGeom prst="rect">
@@ -1407,7 +1439,7 @@
           </a:extLst>
         </p:spPr>
         <p:txBody>
-          <a:bodyPr/>
+          <a:bodyPr anchor="ctr"/>
           <a:lstStyle>
             <a:lvl1pPr>
               <a:defRPr sz="1000">
@@ -1421,7 +1453,7 @@
             <a:pPr algn="r"/>
             <a:fld id="{F7021451-1387-4CA6-816F-3879F97B5CBC}" type="slidenum">
               <a:rPr b="0" lang="en-US"/>
-              <a:t>1003</a:t>
+              <a:t>1004</a:t>
             </a:fld>
             <a:endParaRPr lang="en-US"/>
           </a:p>
@@ -1435,7 +1467,7 @@
 </p:sldLayout>
 </file>
 
-<file path=ppt/slideLayouts/slideLayout4.xml><?xml version="1.0" encoding="utf-8"?>
+<file path=ppt/slideLayouts/slideLayout5.xml><?xml version="1.0" encoding="utf-8"?>
 <p:sldLayout xmlns:a="http://schemas.openxmlformats.org/drawingml/2006/main" xmlns:r="http://schemas.openxmlformats.org/officeDocument/2006/relationships" xmlns:p="http://schemas.openxmlformats.org/presentationml/2006/main" preserve="1">
   <p:cSld name="DARK">
     <p:bg>
@@ -1467,7 +1499,7 @@
         </p:nvSpPr>
         <p:spPr>
           <a:xfrm>
-            <a:off x="6583680" y="6400800"/>
+            <a:off x="6583680" y="6309360"/>
             <a:ext cx="4572000" cy="274320"/>
           </a:xfrm>
           <a:prstGeom prst="rect">
@@ -1506,7 +1538,7 @@
         <p:spPr>
           <a:xfrm>
             <a:off x="548640" y="548640"/>
-            <a:ext cx="7315200" cy="868680"/>
+            <a:ext cx="7040880" cy="868680"/>
           </a:xfrm>
           <a:prstGeom prst="rect">
             <a:avLst/>
@@ -1549,7 +1581,7 @@
         </p:nvSpPr>
         <p:spPr>
           <a:xfrm>
-            <a:off x="11274552" y="6400800"/>
+            <a:off x="11274552" y="6309360"/>
             <a:ext cx="365760" cy="274320"/>
           </a:xfrm>
           <a:prstGeom prst="rect">
@@ -1562,7 +1594,7 @@
           </a:extLst>
         </p:spPr>
         <p:txBody>
-          <a:bodyPr/>
+          <a:bodyPr anchor="ctr"/>
           <a:lstStyle>
             <a:lvl1pPr>
               <a:defRPr sz="1000">
@@ -1576,7 +1608,7 @@
             <a:pPr algn="r"/>
             <a:fld id="{F7021451-1387-4CA6-816F-3879F97B5CBC}" type="slidenum">
               <a:rPr b="0" lang="en-US"/>
-              <a:t>1004</a:t>
+              <a:t>1005</a:t>
             </a:fld>
             <a:endParaRPr lang="en-US"/>
           </a:p>
@@ -1619,7 +1651,7 @@
         </p:nvSpPr>
         <p:spPr>
           <a:xfrm>
-            <a:off x="11274552" y="6400800"/>
+            <a:off x="11274552" y="6309360"/>
             <a:ext cx="365760" cy="274320"/>
           </a:xfrm>
           <a:prstGeom prst="rect">
@@ -1632,7 +1664,7 @@
           </a:extLst>
         </p:spPr>
         <p:txBody>
-          <a:bodyPr/>
+          <a:bodyPr anchor="ctr"/>
           <a:lstStyle>
             <a:lvl1pPr>
               <a:defRPr sz="1000">
@@ -1660,6 +1692,7 @@
     <p:sldLayoutId id="2147483650" r:id="rId2"/>
     <p:sldLayoutId id="2147483651" r:id="rId3"/>
     <p:sldLayoutId id="2147483652" r:id="rId4"/>
+    <p:sldLayoutId id="2147483653" r:id="rId5"/>
   </p:sldLayoutIdLst>
   <p:hf sldNum="0" hdr="0" ftr="0" dt="0"/>
   <p:txStyles>
@@ -2076,7 +2109,7 @@
         <p:spPr>
           <a:xfrm>
             <a:off x="5532120" y="5349240"/>
-            <a:ext cx="5715000" cy="0"/>
+            <a:ext cx="5532120" cy="0"/>
           </a:xfrm>
           <a:prstGeom prst="line">
             <a:avLst/>
@@ -2441,7 +2474,7 @@
         <p:spPr>
           <a:xfrm>
             <a:off x="548640" y="384048"/>
-            <a:ext cx="7315200" cy="868680"/>
+            <a:ext cx="7040880" cy="868680"/>
           </a:xfrm>
           <a:prstGeom prst="rect">
             <a:avLst/>
@@ -2480,7 +2513,7 @@
         <p:spPr>
           <a:xfrm>
             <a:off x="548640" y="1874520"/>
-            <a:ext cx="2148840" cy="960120"/>
+            <a:ext cx="2057400" cy="960120"/>
           </a:xfrm>
           <a:prstGeom prst="roundRect">
             <a:avLst>
@@ -2526,7 +2559,7 @@
         <p:spPr>
           <a:xfrm>
             <a:off x="1115568" y="2011680"/>
-            <a:ext cx="1490472" cy="411480"/>
+            <a:ext cx="1399032" cy="411480"/>
           </a:xfrm>
           <a:prstGeom prst="rect">
             <a:avLst/>
@@ -2562,7 +2595,7 @@
         <p:spPr>
           <a:xfrm>
             <a:off x="1115568" y="2423160"/>
-            <a:ext cx="1490472" cy="347472"/>
+            <a:ext cx="1399032" cy="347472"/>
           </a:xfrm>
           <a:prstGeom prst="rect">
             <a:avLst/>
@@ -2597,8 +2630,8 @@
         </p:nvSpPr>
         <p:spPr>
           <a:xfrm>
-            <a:off x="3520440" y="1874520"/>
-            <a:ext cx="2148840" cy="960120"/>
+            <a:off x="3557016" y="1874520"/>
+            <a:ext cx="2057400" cy="960120"/>
           </a:xfrm>
           <a:prstGeom prst="roundRect">
             <a:avLst>
@@ -2627,7 +2660,7 @@
         </p:blipFill>
         <p:spPr>
           <a:xfrm>
-            <a:off x="3685032" y="2057400"/>
+            <a:off x="3721608" y="2057400"/>
             <a:ext cx="292608" cy="292608"/>
           </a:xfrm>
           <a:prstGeom prst="rect">
@@ -2643,8 +2676,8 @@
         </p:nvSpPr>
         <p:spPr>
           <a:xfrm>
-            <a:off x="4087368" y="2011680"/>
-            <a:ext cx="1490472" cy="411480"/>
+            <a:off x="4123944" y="2011680"/>
+            <a:ext cx="1399032" cy="411480"/>
           </a:xfrm>
           <a:prstGeom prst="rect">
             <a:avLst/>
@@ -2679,8 +2712,8 @@
         </p:nvSpPr>
         <p:spPr>
           <a:xfrm>
-            <a:off x="4087368" y="2423160"/>
-            <a:ext cx="1490472" cy="347472"/>
+            <a:off x="4123944" y="2423160"/>
+            <a:ext cx="1399032" cy="347472"/>
           </a:xfrm>
           <a:prstGeom prst="rect">
             <a:avLst/>
@@ -2715,8 +2748,8 @@
         </p:nvSpPr>
         <p:spPr>
           <a:xfrm>
-            <a:off x="6492240" y="1874520"/>
-            <a:ext cx="2148840" cy="960120"/>
+            <a:off x="6565392" y="1874520"/>
+            <a:ext cx="2057400" cy="960120"/>
           </a:xfrm>
           <a:prstGeom prst="roundRect">
             <a:avLst>
@@ -2745,7 +2778,7 @@
         </p:blipFill>
         <p:spPr>
           <a:xfrm>
-            <a:off x="6656832" y="2057400"/>
+            <a:off x="6729984" y="2057400"/>
             <a:ext cx="292608" cy="292608"/>
           </a:xfrm>
           <a:prstGeom prst="rect">
@@ -2761,8 +2794,8 @@
         </p:nvSpPr>
         <p:spPr>
           <a:xfrm>
-            <a:off x="7059168" y="2011680"/>
-            <a:ext cx="1490472" cy="411480"/>
+            <a:off x="7132320" y="2011680"/>
+            <a:ext cx="1399032" cy="411480"/>
           </a:xfrm>
           <a:prstGeom prst="rect">
             <a:avLst/>
@@ -2797,8 +2830,8 @@
         </p:nvSpPr>
         <p:spPr>
           <a:xfrm>
-            <a:off x="7059168" y="2423160"/>
-            <a:ext cx="1490472" cy="347472"/>
+            <a:off x="7132320" y="2423160"/>
+            <a:ext cx="1399032" cy="347472"/>
           </a:xfrm>
           <a:prstGeom prst="rect">
             <a:avLst/>
@@ -2819,7 +2852,7 @@
                   <a:schemeClr val="tx2"/>
                 </a:solidFill>
               </a:rPr>
-              <a:t>Acquirers and schemes route it onward</a:t>
+              <a:t>Routes it to the bank</a:t>
             </a:r>
             <a:endParaRPr lang="en-US" sz="1100" dirty="0"/>
           </a:p>
@@ -2833,8 +2866,8 @@
         </p:nvSpPr>
         <p:spPr>
           <a:xfrm>
-            <a:off x="9491472" y="1874520"/>
-            <a:ext cx="2148840" cy="960120"/>
+            <a:off x="9582912" y="1874520"/>
+            <a:ext cx="2057400" cy="960120"/>
           </a:xfrm>
           <a:prstGeom prst="roundRect">
             <a:avLst>
@@ -2870,7 +2903,7 @@
         </p:blipFill>
         <p:spPr>
           <a:xfrm>
-            <a:off x="9656064" y="2057400"/>
+            <a:off x="9747504" y="2057400"/>
             <a:ext cx="292608" cy="292608"/>
           </a:xfrm>
           <a:prstGeom prst="rect">
@@ -2886,8 +2919,8 @@
         </p:nvSpPr>
         <p:spPr>
           <a:xfrm>
-            <a:off x="10058400" y="2011680"/>
-            <a:ext cx="1490472" cy="411480"/>
+            <a:off x="10149840" y="2011680"/>
+            <a:ext cx="1399032" cy="411480"/>
           </a:xfrm>
           <a:prstGeom prst="rect">
             <a:avLst/>
@@ -2922,8 +2955,8 @@
         </p:nvSpPr>
         <p:spPr>
           <a:xfrm>
-            <a:off x="10058400" y="2423160"/>
-            <a:ext cx="1490472" cy="347472"/>
+            <a:off x="10149840" y="2423160"/>
+            <a:ext cx="1399032" cy="347472"/>
           </a:xfrm>
           <a:prstGeom prst="rect">
             <a:avLst/>
@@ -2958,8 +2991,8 @@
         </p:nvSpPr>
         <p:spPr>
           <a:xfrm>
-            <a:off x="2697480" y="2354580"/>
-            <a:ext cx="804672" cy="0"/>
+            <a:off x="2642616" y="2354580"/>
+            <a:ext cx="859536" cy="0"/>
           </a:xfrm>
           <a:prstGeom prst="line">
             <a:avLst/>
@@ -2982,8 +3015,8 @@
         </p:nvSpPr>
         <p:spPr>
           <a:xfrm>
-            <a:off x="5669280" y="2354580"/>
-            <a:ext cx="804672" cy="0"/>
+            <a:off x="5650992" y="2354580"/>
+            <a:ext cx="859536" cy="0"/>
           </a:xfrm>
           <a:prstGeom prst="line">
             <a:avLst/>
@@ -3006,8 +3039,8 @@
         </p:nvSpPr>
         <p:spPr>
           <a:xfrm>
-            <a:off x="8641080" y="2354580"/>
-            <a:ext cx="832104" cy="0"/>
+            <a:off x="8659368" y="2354580"/>
+            <a:ext cx="868680" cy="0"/>
           </a:xfrm>
           <a:prstGeom prst="line">
             <a:avLst/>
@@ -3030,7 +3063,7 @@
         </p:nvSpPr>
         <p:spPr>
           <a:xfrm>
-            <a:off x="5833872" y="2116836"/>
+            <a:off x="5852160" y="2116836"/>
             <a:ext cx="475488" cy="475488"/>
           </a:xfrm>
           <a:prstGeom prst="ellipse">
@@ -3068,7 +3101,7 @@
         </p:blipFill>
         <p:spPr>
           <a:xfrm>
-            <a:off x="5952744" y="2235708"/>
+            <a:off x="5971032" y="2235708"/>
             <a:ext cx="237744" cy="237744"/>
           </a:xfrm>
           <a:prstGeom prst="rect">
@@ -3084,7 +3117,7 @@
         </p:nvSpPr>
         <p:spPr>
           <a:xfrm>
-            <a:off x="4526280" y="3017520"/>
+            <a:off x="4535424" y="3017520"/>
             <a:ext cx="3108960" cy="594360"/>
           </a:xfrm>
           <a:prstGeom prst="rect">
@@ -3134,8 +3167,8 @@
         </p:nvSpPr>
         <p:spPr>
           <a:xfrm>
-            <a:off x="7315200" y="1417320"/>
-            <a:ext cx="4325112" cy="320040"/>
+            <a:off x="6565392" y="1307592"/>
+            <a:ext cx="5074920" cy="320040"/>
           </a:xfrm>
           <a:prstGeom prst="rect">
             <a:avLst/>
@@ -3170,8 +3203,8 @@
         </p:nvSpPr>
         <p:spPr>
           <a:xfrm>
-            <a:off x="7571232" y="1764792"/>
-            <a:ext cx="3813048" cy="0"/>
+            <a:off x="6565392" y="1673352"/>
+            <a:ext cx="5074920" cy="0"/>
           </a:xfrm>
           <a:prstGeom prst="line">
             <a:avLst/>
@@ -3686,7 +3719,7 @@
         </p:nvSpPr>
         <p:spPr>
           <a:xfrm>
-            <a:off x="548640" y="6400800"/>
+            <a:off x="548640" y="6309360"/>
             <a:ext cx="5852160" cy="274320"/>
           </a:xfrm>
           <a:prstGeom prst="rect">
@@ -3696,7 +3729,7 @@
           <a:ln/>
         </p:spPr>
         <p:txBody>
-          <a:bodyPr wrap="square" lIns="0" tIns="0" rIns="0" bIns="0" rtlCol="0" anchor="t"/>
+          <a:bodyPr wrap="square" lIns="0" tIns="0" rIns="0" bIns="0" rtlCol="0" anchor="ctr"/>
           <a:lstStyle/>
           <a:p>
             <a:pPr indent="0" marL="0">
@@ -3726,7 +3759,7 @@
         </p:nvSpPr>
         <p:spPr>
           <a:xfrm>
-            <a:off x="11274552" y="6400800"/>
+            <a:off x="11274552" y="6309360"/>
             <a:ext cx="365760" cy="274320"/>
           </a:xfrm>
           <a:prstGeom prst="rect">
@@ -3739,7 +3772,7 @@
           </a:extLst>
         </p:spPr>
         <p:txBody>
-          <a:bodyPr/>
+          <a:bodyPr anchor="ctr"/>
           <a:lstStyle>
             <a:lvl1pPr>
               <a:defRPr sz="1000">
@@ -3795,7 +3828,7 @@
         <p:spPr>
           <a:xfrm>
             <a:off x="548640" y="384048"/>
-            <a:ext cx="7315200" cy="868680"/>
+            <a:ext cx="7040880" cy="868680"/>
           </a:xfrm>
           <a:prstGeom prst="rect">
             <a:avLst/>
@@ -3986,12 +4019,12 @@
         </p:nvSpPr>
         <p:spPr>
           <a:xfrm>
-            <a:off x="548640" y="1600200"/>
-            <a:ext cx="2542032" cy="2331720"/>
+            <a:off x="548640" y="1691640"/>
+            <a:ext cx="2542032" cy="2286000"/>
           </a:xfrm>
           <a:prstGeom prst="roundRect">
             <a:avLst>
-              <a:gd name="adj" fmla="val 3922"/>
+              <a:gd name="adj" fmla="val 4000"/>
             </a:avLst>
           </a:prstGeom>
           <a:solidFill>
@@ -4008,7 +4041,7 @@
         </p:nvSpPr>
         <p:spPr>
           <a:xfrm>
-            <a:off x="777240" y="1828800"/>
+            <a:off x="777240" y="1920240"/>
             <a:ext cx="420624" cy="420624"/>
           </a:xfrm>
           <a:prstGeom prst="ellipse">
@@ -4046,7 +4079,7 @@
         </p:nvSpPr>
         <p:spPr>
           <a:xfrm>
-            <a:off x="1325880" y="1783080"/>
+            <a:off x="1325880" y="1874520"/>
             <a:ext cx="1627632" cy="512064"/>
           </a:xfrm>
           <a:prstGeom prst="rect">
@@ -4082,8 +4115,8 @@
         </p:nvSpPr>
         <p:spPr>
           <a:xfrm>
-            <a:off x="777240" y="2468880"/>
-            <a:ext cx="2130552" cy="1371600"/>
+            <a:off x="777240" y="2560320"/>
+            <a:ext cx="2130552" cy="1325880"/>
           </a:xfrm>
           <a:prstGeom prst="rect">
             <a:avLst/>
@@ -4140,7 +4173,7 @@
         </p:nvSpPr>
         <p:spPr>
           <a:xfrm>
-            <a:off x="3127248" y="2766060"/>
+            <a:off x="3127248" y="2834640"/>
             <a:ext cx="231343" cy="0"/>
           </a:xfrm>
           <a:prstGeom prst="line">
@@ -4164,12 +4197,12 @@
         </p:nvSpPr>
         <p:spPr>
           <a:xfrm>
-            <a:off x="3395167" y="1600200"/>
-            <a:ext cx="2542032" cy="2331720"/>
+            <a:off x="3395167" y="1691640"/>
+            <a:ext cx="2542032" cy="2286000"/>
           </a:xfrm>
           <a:prstGeom prst="roundRect">
             <a:avLst>
-              <a:gd name="adj" fmla="val 3922"/>
+              <a:gd name="adj" fmla="val 4000"/>
             </a:avLst>
           </a:prstGeom>
           <a:solidFill>
@@ -4186,7 +4219,7 @@
         </p:nvSpPr>
         <p:spPr>
           <a:xfrm>
-            <a:off x="3623767" y="1828800"/>
+            <a:off x="3623767" y="1920240"/>
             <a:ext cx="420624" cy="420624"/>
           </a:xfrm>
           <a:prstGeom prst="ellipse">
@@ -4224,7 +4257,7 @@
         </p:nvSpPr>
         <p:spPr>
           <a:xfrm>
-            <a:off x="4172407" y="1783080"/>
+            <a:off x="4172407" y="1874520"/>
             <a:ext cx="1627632" cy="512064"/>
           </a:xfrm>
           <a:prstGeom prst="rect">
@@ -4260,8 +4293,8 @@
         </p:nvSpPr>
         <p:spPr>
           <a:xfrm>
-            <a:off x="3623767" y="2468880"/>
-            <a:ext cx="2130552" cy="1371600"/>
+            <a:off x="3623767" y="2560320"/>
+            <a:ext cx="2130552" cy="1325880"/>
           </a:xfrm>
           <a:prstGeom prst="rect">
             <a:avLst/>
@@ -4318,7 +4351,7 @@
         </p:nvSpPr>
         <p:spPr>
           <a:xfrm>
-            <a:off x="5973775" y="2766060"/>
+            <a:off x="5973775" y="2834640"/>
             <a:ext cx="231343" cy="0"/>
           </a:xfrm>
           <a:prstGeom prst="line">
@@ -4342,12 +4375,12 @@
         </p:nvSpPr>
         <p:spPr>
           <a:xfrm>
-            <a:off x="6241694" y="1600200"/>
-            <a:ext cx="2542032" cy="2331720"/>
+            <a:off x="6241694" y="1691640"/>
+            <a:ext cx="2542032" cy="2286000"/>
           </a:xfrm>
           <a:prstGeom prst="roundRect">
             <a:avLst>
-              <a:gd name="adj" fmla="val 3922"/>
+              <a:gd name="adj" fmla="val 4000"/>
             </a:avLst>
           </a:prstGeom>
           <a:solidFill>
@@ -4371,7 +4404,7 @@
         </p:nvSpPr>
         <p:spPr>
           <a:xfrm>
-            <a:off x="6470294" y="1828800"/>
+            <a:off x="6470294" y="1920240"/>
             <a:ext cx="420624" cy="420624"/>
           </a:xfrm>
           <a:prstGeom prst="ellipse">
@@ -4409,7 +4442,7 @@
         </p:nvSpPr>
         <p:spPr>
           <a:xfrm>
-            <a:off x="7018934" y="1783080"/>
+            <a:off x="7018934" y="1874520"/>
             <a:ext cx="1307592" cy="512064"/>
           </a:xfrm>
           <a:prstGeom prst="rect">
@@ -4453,7 +4486,7 @@
         </p:blipFill>
         <p:spPr>
           <a:xfrm>
-            <a:off x="8344814" y="1901952"/>
+            <a:off x="8344814" y="1993392"/>
             <a:ext cx="274320" cy="274320"/>
           </a:xfrm>
           <a:prstGeom prst="rect">
@@ -4469,8 +4502,8 @@
         </p:nvSpPr>
         <p:spPr>
           <a:xfrm>
-            <a:off x="6470294" y="2468880"/>
-            <a:ext cx="2130552" cy="1371600"/>
+            <a:off x="6470294" y="2560320"/>
+            <a:ext cx="2130552" cy="1325880"/>
           </a:xfrm>
           <a:prstGeom prst="rect">
             <a:avLst/>
@@ -4527,7 +4560,7 @@
         </p:nvSpPr>
         <p:spPr>
           <a:xfrm>
-            <a:off x="8820302" y="2766060"/>
+            <a:off x="8820302" y="2834640"/>
             <a:ext cx="231343" cy="0"/>
           </a:xfrm>
           <a:prstGeom prst="line">
@@ -4551,12 +4584,12 @@
         </p:nvSpPr>
         <p:spPr>
           <a:xfrm>
-            <a:off x="9088222" y="1600200"/>
-            <a:ext cx="2542032" cy="2331720"/>
+            <a:off x="9088222" y="1691640"/>
+            <a:ext cx="2542032" cy="2286000"/>
           </a:xfrm>
           <a:prstGeom prst="roundRect">
             <a:avLst>
-              <a:gd name="adj" fmla="val 3922"/>
+              <a:gd name="adj" fmla="val 4000"/>
             </a:avLst>
           </a:prstGeom>
           <a:solidFill>
@@ -4573,7 +4606,7 @@
         </p:nvSpPr>
         <p:spPr>
           <a:xfrm>
-            <a:off x="9316822" y="1828800"/>
+            <a:off x="9316822" y="1920240"/>
             <a:ext cx="420624" cy="420624"/>
           </a:xfrm>
           <a:prstGeom prst="ellipse">
@@ -4611,7 +4644,7 @@
         </p:nvSpPr>
         <p:spPr>
           <a:xfrm>
-            <a:off x="9865462" y="1783080"/>
+            <a:off x="9865462" y="1874520"/>
             <a:ext cx="1627632" cy="512064"/>
           </a:xfrm>
           <a:prstGeom prst="rect">
@@ -4647,8 +4680,8 @@
         </p:nvSpPr>
         <p:spPr>
           <a:xfrm>
-            <a:off x="9316822" y="2468880"/>
-            <a:ext cx="2130552" cy="1371600"/>
+            <a:off x="9316822" y="2560320"/>
+            <a:ext cx="2130552" cy="1325880"/>
           </a:xfrm>
           <a:prstGeom prst="rect">
             <a:avLst/>
@@ -4705,8 +4738,8 @@
         </p:nvSpPr>
         <p:spPr>
           <a:xfrm>
-            <a:off x="10359238" y="3931920"/>
-            <a:ext cx="0" cy="347472"/>
+            <a:off x="10359238" y="3977640"/>
+            <a:ext cx="0" cy="411480"/>
           </a:xfrm>
           <a:prstGeom prst="line">
             <a:avLst/>
@@ -4729,7 +4762,7 @@
         </p:nvSpPr>
         <p:spPr>
           <a:xfrm flipH="1">
-            <a:off x="1819656" y="4279392"/>
+            <a:off x="1819656" y="4389120"/>
             <a:ext cx="8539582" cy="0"/>
           </a:xfrm>
           <a:prstGeom prst="line">
@@ -4753,8 +4786,8 @@
         </p:nvSpPr>
         <p:spPr>
           <a:xfrm flipV="1">
-            <a:off x="1819656" y="3950208"/>
-            <a:ext cx="0" cy="329184"/>
+            <a:off x="1819656" y="3995928"/>
+            <a:ext cx="0" cy="393192"/>
           </a:xfrm>
           <a:prstGeom prst="line">
             <a:avLst/>
@@ -4777,7 +4810,7 @@
         </p:nvSpPr>
         <p:spPr>
           <a:xfrm>
-            <a:off x="2103120" y="4105656"/>
+            <a:off x="2103120" y="4215384"/>
             <a:ext cx="7955280" cy="347472"/>
           </a:xfrm>
           <a:prstGeom prst="roundRect">
@@ -4804,7 +4837,7 @@
         </p:nvSpPr>
         <p:spPr>
           <a:xfrm>
-            <a:off x="2194560" y="4105656"/>
+            <a:off x="2194560" y="4215384"/>
             <a:ext cx="7772400" cy="347472"/>
           </a:xfrm>
           <a:prstGeom prst="rect">
@@ -4851,12 +4884,12 @@
         </p:nvSpPr>
         <p:spPr>
           <a:xfrm>
-            <a:off x="7973568" y="1143000"/>
-            <a:ext cx="3666744" cy="329184"/>
+            <a:off x="7973568" y="1097280"/>
+            <a:ext cx="3666744" cy="310896"/>
           </a:xfrm>
           <a:prstGeom prst="roundRect">
             <a:avLst>
-              <a:gd name="adj" fmla="val 47222"/>
+              <a:gd name="adj" fmla="val 50000"/>
             </a:avLst>
           </a:prstGeom>
           <a:solidFill>
@@ -4891,7 +4924,7 @@
         </p:nvSpPr>
         <p:spPr>
           <a:xfrm>
-            <a:off x="548640" y="4937760"/>
+            <a:off x="548640" y="4846320"/>
             <a:ext cx="11091672" cy="1097280"/>
           </a:xfrm>
           <a:prstGeom prst="roundRect">
@@ -4920,7 +4953,7 @@
         </p:nvSpPr>
         <p:spPr>
           <a:xfrm>
-            <a:off x="822960" y="5184648"/>
+            <a:off x="822960" y="5093208"/>
             <a:ext cx="603504" cy="603504"/>
           </a:xfrm>
           <a:prstGeom prst="ellipse">
@@ -4950,7 +4983,7 @@
         </p:blipFill>
         <p:spPr>
           <a:xfrm>
-            <a:off x="973836" y="5335524"/>
+            <a:off x="973836" y="5244084"/>
             <a:ext cx="301752" cy="301752"/>
           </a:xfrm>
           <a:prstGeom prst="rect">
@@ -4966,7 +4999,7 @@
         </p:nvSpPr>
         <p:spPr>
           <a:xfrm>
-            <a:off x="1645920" y="5120640"/>
+            <a:off x="1645920" y="5029200"/>
             <a:ext cx="6858000" cy="365760"/>
           </a:xfrm>
           <a:prstGeom prst="rect">
@@ -5002,7 +5035,7 @@
         </p:nvSpPr>
         <p:spPr>
           <a:xfrm>
-            <a:off x="1645920" y="5486400"/>
+            <a:off x="1645920" y="5394960"/>
             <a:ext cx="6949440" cy="457200"/>
           </a:xfrm>
           <a:prstGeom prst="rect">
@@ -5038,8 +5071,8 @@
         </p:nvSpPr>
         <p:spPr>
           <a:xfrm>
-            <a:off x="8778240" y="5065776"/>
-            <a:ext cx="2697480" cy="868680"/>
+            <a:off x="8595360" y="4956048"/>
+            <a:ext cx="2743200" cy="914400"/>
           </a:xfrm>
           <a:prstGeom prst="rect">
             <a:avLst/>
@@ -5074,7 +5107,21 @@
                   <a:schemeClr val="tx1"/>
                 </a:solidFill>
               </a:rPr>
-              <a:t>to update the Register after a major designation</a:t>
+              <a:t>to update the Register</a:t>
+            </a:r>
+            <a:endParaRPr lang="en-US" sz="3000" dirty="0"/>
+          </a:p>
+          <a:p>
+            <a:pPr algn="r" indent="0" marL="0">
+              <a:buNone/>
+            </a:pPr>
+            <a:r>
+              <a:rPr lang="en-US" sz="1100" dirty="0">
+                <a:solidFill>
+                  <a:schemeClr val="tx1"/>
+                </a:solidFill>
+              </a:rPr>
+              <a:t>after a major designation</a:t>
             </a:r>
             <a:endParaRPr lang="en-US" sz="3000" dirty="0"/>
           </a:p>
@@ -5088,7 +5135,7 @@
         </p:nvSpPr>
         <p:spPr>
           <a:xfrm>
-            <a:off x="548640" y="6400800"/>
+            <a:off x="548640" y="6309360"/>
             <a:ext cx="5852160" cy="274320"/>
           </a:xfrm>
           <a:prstGeom prst="rect">
@@ -5098,7 +5145,7 @@
           <a:ln/>
         </p:spPr>
         <p:txBody>
-          <a:bodyPr wrap="square" lIns="0" tIns="0" rIns="0" bIns="0" rtlCol="0" anchor="t"/>
+          <a:bodyPr wrap="square" lIns="0" tIns="0" rIns="0" bIns="0" rtlCol="0" anchor="ctr"/>
           <a:lstStyle/>
           <a:p>
             <a:pPr indent="0" marL="0">
@@ -5128,7 +5175,7 @@
         </p:nvSpPr>
         <p:spPr>
           <a:xfrm>
-            <a:off x="11274552" y="6400800"/>
+            <a:off x="11274552" y="6309360"/>
             <a:ext cx="365760" cy="274320"/>
           </a:xfrm>
           <a:prstGeom prst="rect">
@@ -5141,7 +5188,7 @@
           </a:extLst>
         </p:spPr>
         <p:txBody>
-          <a:bodyPr/>
+          <a:bodyPr anchor="ctr"/>
           <a:lstStyle>
             <a:lvl1pPr>
               <a:defRPr sz="1000">
@@ -5197,7 +5244,7 @@
         <p:spPr>
           <a:xfrm>
             <a:off x="548640" y="384048"/>
-            <a:ext cx="7315200" cy="868680"/>
+            <a:ext cx="7040880" cy="868680"/>
           </a:xfrm>
           <a:prstGeom prst="rect">
             <a:avLst/>
@@ -5648,12 +5695,12 @@
         </p:nvSpPr>
         <p:spPr>
           <a:xfrm>
-            <a:off x="548640" y="2542032"/>
-            <a:ext cx="2697480" cy="1298448"/>
+            <a:off x="548640" y="2514600"/>
+            <a:ext cx="2697480" cy="1243584"/>
           </a:xfrm>
           <a:prstGeom prst="roundRect">
             <a:avLst>
-              <a:gd name="adj" fmla="val 7042"/>
+              <a:gd name="adj" fmla="val 7353"/>
             </a:avLst>
           </a:prstGeom>
           <a:solidFill>
@@ -5678,7 +5725,7 @@
         </p:blipFill>
         <p:spPr>
           <a:xfrm>
-            <a:off x="777240" y="2816352"/>
+            <a:off x="777240" y="2788920"/>
             <a:ext cx="347472" cy="347472"/>
           </a:xfrm>
           <a:prstGeom prst="rect">
@@ -5694,7 +5741,7 @@
         </p:nvSpPr>
         <p:spPr>
           <a:xfrm>
-            <a:off x="1280160" y="2770632"/>
+            <a:off x="1280160" y="2743200"/>
             <a:ext cx="1874520" cy="411480"/>
           </a:xfrm>
           <a:prstGeom prst="rect">
@@ -5730,7 +5777,7 @@
         </p:nvSpPr>
         <p:spPr>
           <a:xfrm>
-            <a:off x="777240" y="3273552"/>
+            <a:off x="777240" y="3246120"/>
             <a:ext cx="2331720" cy="457200"/>
           </a:xfrm>
           <a:prstGeom prst="rect">
@@ -5766,7 +5813,7 @@
         </p:nvSpPr>
         <p:spPr>
           <a:xfrm>
-            <a:off x="3264408" y="3191256"/>
+            <a:off x="3264408" y="3136392"/>
             <a:ext cx="237744" cy="0"/>
           </a:xfrm>
           <a:prstGeom prst="line">
@@ -5790,12 +5837,12 @@
         </p:nvSpPr>
         <p:spPr>
           <a:xfrm>
-            <a:off x="3520440" y="2542032"/>
-            <a:ext cx="3611880" cy="1298448"/>
+            <a:off x="3520440" y="2514600"/>
+            <a:ext cx="3383280" cy="1243584"/>
           </a:xfrm>
           <a:prstGeom prst="roundRect">
             <a:avLst>
-              <a:gd name="adj" fmla="val 7042"/>
+              <a:gd name="adj" fmla="val 7353"/>
             </a:avLst>
           </a:prstGeom>
           <a:solidFill>
@@ -5817,8 +5864,8 @@
         </p:nvSpPr>
         <p:spPr>
           <a:xfrm>
-            <a:off x="3749040" y="2798064"/>
-            <a:ext cx="3200400" cy="411480"/>
+            <a:off x="3749040" y="2715768"/>
+            <a:ext cx="3017520" cy="548640"/>
           </a:xfrm>
           <a:prstGeom prst="rect">
             <a:avLst/>
@@ -5853,8 +5900,8 @@
         </p:nvSpPr>
         <p:spPr>
           <a:xfrm>
-            <a:off x="3749040" y="3291840"/>
-            <a:ext cx="3200400" cy="320040"/>
+            <a:off x="3749040" y="3300984"/>
+            <a:ext cx="3017520" cy="320040"/>
           </a:xfrm>
           <a:prstGeom prst="rect">
             <a:avLst/>
@@ -5889,8 +5936,8 @@
         </p:nvSpPr>
         <p:spPr>
           <a:xfrm>
-            <a:off x="7150608" y="3191256"/>
-            <a:ext cx="100584" cy="0"/>
+            <a:off x="6922008" y="3136392"/>
+            <a:ext cx="310896" cy="0"/>
           </a:xfrm>
           <a:prstGeom prst="line">
             <a:avLst/>
@@ -5913,7 +5960,7 @@
         </p:nvSpPr>
         <p:spPr>
           <a:xfrm>
-            <a:off x="7269480" y="2715768"/>
+            <a:off x="7269480" y="2660904"/>
             <a:ext cx="1188720" cy="950976"/>
           </a:xfrm>
           <a:prstGeom prst="diamond">
@@ -5955,7 +6002,7 @@
         </p:nvSpPr>
         <p:spPr>
           <a:xfrm>
-            <a:off x="8458200" y="3191256"/>
+            <a:off x="8458200" y="3136392"/>
             <a:ext cx="45720" cy="0"/>
           </a:xfrm>
           <a:prstGeom prst="line">
@@ -5979,8 +6026,8 @@
         </p:nvSpPr>
         <p:spPr>
           <a:xfrm flipV="1">
-            <a:off x="8503920" y="2816352"/>
-            <a:ext cx="0" cy="374904"/>
+            <a:off x="8503920" y="2788920"/>
+            <a:ext cx="0" cy="347472"/>
           </a:xfrm>
           <a:prstGeom prst="line">
             <a:avLst/>
@@ -6003,7 +6050,7 @@
         </p:nvSpPr>
         <p:spPr>
           <a:xfrm>
-            <a:off x="8503920" y="2816352"/>
+            <a:off x="8503920" y="2788920"/>
             <a:ext cx="100584" cy="0"/>
           </a:xfrm>
           <a:prstGeom prst="line">
@@ -6027,8 +6074,8 @@
         </p:nvSpPr>
         <p:spPr>
           <a:xfrm>
-            <a:off x="8503920" y="3191256"/>
-            <a:ext cx="0" cy="374904"/>
+            <a:off x="8503920" y="3136392"/>
+            <a:ext cx="0" cy="347472"/>
           </a:xfrm>
           <a:prstGeom prst="line">
             <a:avLst/>
@@ -6051,7 +6098,7 @@
         </p:nvSpPr>
         <p:spPr>
           <a:xfrm>
-            <a:off x="8503920" y="3566160"/>
+            <a:off x="8503920" y="3483864"/>
             <a:ext cx="100584" cy="0"/>
           </a:xfrm>
           <a:prstGeom prst="line">
@@ -6075,7 +6122,7 @@
         </p:nvSpPr>
         <p:spPr>
           <a:xfrm>
-            <a:off x="8622792" y="2542032"/>
+            <a:off x="8622792" y="2514600"/>
             <a:ext cx="3017520" cy="548640"/>
           </a:xfrm>
           <a:prstGeom prst="roundRect">
@@ -6099,7 +6146,7 @@
         </p:nvSpPr>
         <p:spPr>
           <a:xfrm>
-            <a:off x="8769096" y="2660904"/>
+            <a:off x="8769096" y="2633472"/>
             <a:ext cx="310896" cy="310896"/>
           </a:xfrm>
           <a:prstGeom prst="ellipse">
@@ -6137,7 +6184,7 @@
         </p:nvSpPr>
         <p:spPr>
           <a:xfrm>
-            <a:off x="9226296" y="2542032"/>
+            <a:off x="9226296" y="2514600"/>
             <a:ext cx="2322576" cy="548640"/>
           </a:xfrm>
           <a:prstGeom prst="rect">
@@ -6173,7 +6220,7 @@
         </p:nvSpPr>
         <p:spPr>
           <a:xfrm>
-            <a:off x="8622792" y="3291840"/>
+            <a:off x="8622792" y="3209544"/>
             <a:ext cx="3017520" cy="548640"/>
           </a:xfrm>
           <a:prstGeom prst="roundRect">
@@ -6197,7 +6244,7 @@
         </p:nvSpPr>
         <p:spPr>
           <a:xfrm>
-            <a:off x="8769096" y="3410712"/>
+            <a:off x="8769096" y="3328416"/>
             <a:ext cx="310896" cy="310896"/>
           </a:xfrm>
           <a:prstGeom prst="ellipse">
@@ -6235,7 +6282,7 @@
         </p:nvSpPr>
         <p:spPr>
           <a:xfrm>
-            <a:off x="9226296" y="3291840"/>
+            <a:off x="9226296" y="3209544"/>
             <a:ext cx="2322576" cy="548640"/>
           </a:xfrm>
           <a:prstGeom prst="rect">
@@ -6271,12 +6318,12 @@
         </p:nvSpPr>
         <p:spPr>
           <a:xfrm>
-            <a:off x="548640" y="4114800"/>
-            <a:ext cx="2697480" cy="1298448"/>
+            <a:off x="548640" y="3986784"/>
+            <a:ext cx="2697480" cy="1243584"/>
           </a:xfrm>
           <a:prstGeom prst="roundRect">
             <a:avLst>
-              <a:gd name="adj" fmla="val 7042"/>
+              <a:gd name="adj" fmla="val 7353"/>
             </a:avLst>
           </a:prstGeom>
           <a:solidFill>
@@ -6301,7 +6348,7 @@
         </p:blipFill>
         <p:spPr>
           <a:xfrm>
-            <a:off x="777240" y="4389120"/>
+            <a:off x="777240" y="4261104"/>
             <a:ext cx="347472" cy="347472"/>
           </a:xfrm>
           <a:prstGeom prst="rect">
@@ -6317,7 +6364,7 @@
         </p:nvSpPr>
         <p:spPr>
           <a:xfrm>
-            <a:off x="1280160" y="4343400"/>
+            <a:off x="1280160" y="4215384"/>
             <a:ext cx="1874520" cy="411480"/>
           </a:xfrm>
           <a:prstGeom prst="rect">
@@ -6353,7 +6400,7 @@
         </p:nvSpPr>
         <p:spPr>
           <a:xfrm>
-            <a:off x="777240" y="4846320"/>
+            <a:off x="777240" y="4718304"/>
             <a:ext cx="2331720" cy="457200"/>
           </a:xfrm>
           <a:prstGeom prst="rect">
@@ -6389,7 +6436,7 @@
         </p:nvSpPr>
         <p:spPr>
           <a:xfrm>
-            <a:off x="3264408" y="4764024"/>
+            <a:off x="3264408" y="4608576"/>
             <a:ext cx="237744" cy="0"/>
           </a:xfrm>
           <a:prstGeom prst="line">
@@ -6413,12 +6460,12 @@
         </p:nvSpPr>
         <p:spPr>
           <a:xfrm>
-            <a:off x="3520440" y="4114800"/>
-            <a:ext cx="3611880" cy="1298448"/>
+            <a:off x="3520440" y="3986784"/>
+            <a:ext cx="3383280" cy="1243584"/>
           </a:xfrm>
           <a:prstGeom prst="roundRect">
             <a:avLst>
-              <a:gd name="adj" fmla="val 7042"/>
+              <a:gd name="adj" fmla="val 7353"/>
             </a:avLst>
           </a:prstGeom>
           <a:solidFill>
@@ -6440,8 +6487,8 @@
         </p:nvSpPr>
         <p:spPr>
           <a:xfrm>
-            <a:off x="3749040" y="4370832"/>
-            <a:ext cx="3200400" cy="411480"/>
+            <a:off x="3749040" y="4187952"/>
+            <a:ext cx="3017520" cy="548640"/>
           </a:xfrm>
           <a:prstGeom prst="rect">
             <a:avLst/>
@@ -6476,8 +6523,8 @@
         </p:nvSpPr>
         <p:spPr>
           <a:xfrm>
-            <a:off x="3749040" y="4864608"/>
-            <a:ext cx="3200400" cy="320040"/>
+            <a:off x="3749040" y="4773168"/>
+            <a:ext cx="3017520" cy="320040"/>
           </a:xfrm>
           <a:prstGeom prst="rect">
             <a:avLst/>
@@ -6512,8 +6559,8 @@
         </p:nvSpPr>
         <p:spPr>
           <a:xfrm>
-            <a:off x="7150608" y="4764024"/>
-            <a:ext cx="100584" cy="0"/>
+            <a:off x="6922008" y="4608576"/>
+            <a:ext cx="310896" cy="0"/>
           </a:xfrm>
           <a:prstGeom prst="line">
             <a:avLst/>
@@ -6536,7 +6583,7 @@
         </p:nvSpPr>
         <p:spPr>
           <a:xfrm>
-            <a:off x="7269480" y="4288536"/>
+            <a:off x="7269480" y="4133088"/>
             <a:ext cx="1188720" cy="950976"/>
           </a:xfrm>
           <a:prstGeom prst="diamond">
@@ -6578,7 +6625,7 @@
         </p:nvSpPr>
         <p:spPr>
           <a:xfrm>
-            <a:off x="8458200" y="4764024"/>
+            <a:off x="8458200" y="4608576"/>
             <a:ext cx="45720" cy="0"/>
           </a:xfrm>
           <a:prstGeom prst="line">
@@ -6602,8 +6649,8 @@
         </p:nvSpPr>
         <p:spPr>
           <a:xfrm flipV="1">
-            <a:off x="8503920" y="4389120"/>
-            <a:ext cx="0" cy="374904"/>
+            <a:off x="8503920" y="4261104"/>
+            <a:ext cx="0" cy="347472"/>
           </a:xfrm>
           <a:prstGeom prst="line">
             <a:avLst/>
@@ -6626,7 +6673,7 @@
         </p:nvSpPr>
         <p:spPr>
           <a:xfrm>
-            <a:off x="8503920" y="4389120"/>
+            <a:off x="8503920" y="4261104"/>
             <a:ext cx="100584" cy="0"/>
           </a:xfrm>
           <a:prstGeom prst="line">
@@ -6650,8 +6697,8 @@
         </p:nvSpPr>
         <p:spPr>
           <a:xfrm>
-            <a:off x="8503920" y="4764024"/>
-            <a:ext cx="0" cy="374904"/>
+            <a:off x="8503920" y="4608576"/>
+            <a:ext cx="0" cy="347472"/>
           </a:xfrm>
           <a:prstGeom prst="line">
             <a:avLst/>
@@ -6674,7 +6721,7 @@
         </p:nvSpPr>
         <p:spPr>
           <a:xfrm>
-            <a:off x="8503920" y="5138928"/>
+            <a:off x="8503920" y="4956048"/>
             <a:ext cx="100584" cy="0"/>
           </a:xfrm>
           <a:prstGeom prst="line">
@@ -6698,7 +6745,7 @@
         </p:nvSpPr>
         <p:spPr>
           <a:xfrm>
-            <a:off x="8622792" y="4114800"/>
+            <a:off x="8622792" y="3986784"/>
             <a:ext cx="3017520" cy="548640"/>
           </a:xfrm>
           <a:prstGeom prst="roundRect">
@@ -6722,7 +6769,7 @@
         </p:nvSpPr>
         <p:spPr>
           <a:xfrm>
-            <a:off x="8769096" y="4233672"/>
+            <a:off x="8769096" y="4105656"/>
             <a:ext cx="310896" cy="310896"/>
           </a:xfrm>
           <a:prstGeom prst="ellipse">
@@ -6760,7 +6807,7 @@
         </p:nvSpPr>
         <p:spPr>
           <a:xfrm>
-            <a:off x="9226296" y="4114800"/>
+            <a:off x="9226296" y="3986784"/>
             <a:ext cx="2322576" cy="548640"/>
           </a:xfrm>
           <a:prstGeom prst="rect">
@@ -6796,7 +6843,7 @@
         </p:nvSpPr>
         <p:spPr>
           <a:xfrm>
-            <a:off x="8622792" y="4864608"/>
+            <a:off x="8622792" y="4681728"/>
             <a:ext cx="3017520" cy="548640"/>
           </a:xfrm>
           <a:prstGeom prst="roundRect">
@@ -6820,7 +6867,7 @@
         </p:nvSpPr>
         <p:spPr>
           <a:xfrm>
-            <a:off x="8769096" y="4983480"/>
+            <a:off x="8769096" y="4800600"/>
             <a:ext cx="310896" cy="310896"/>
           </a:xfrm>
           <a:prstGeom prst="ellipse">
@@ -6858,7 +6905,7 @@
         </p:nvSpPr>
         <p:spPr>
           <a:xfrm>
-            <a:off x="9226296" y="4864608"/>
+            <a:off x="9226296" y="4681728"/>
             <a:ext cx="2322576" cy="548640"/>
           </a:xfrm>
           <a:prstGeom prst="rect">
@@ -6894,12 +6941,12 @@
         </p:nvSpPr>
         <p:spPr>
           <a:xfrm>
-            <a:off x="548640" y="5669280"/>
-            <a:ext cx="11091672" cy="475488"/>
+            <a:off x="548640" y="5486400"/>
+            <a:ext cx="11091672" cy="457200"/>
           </a:xfrm>
           <a:prstGeom prst="roundRect">
             <a:avLst>
-              <a:gd name="adj" fmla="val 19231"/>
+              <a:gd name="adj" fmla="val 20000"/>
             </a:avLst>
           </a:prstGeom>
           <a:solidFill>
@@ -6916,8 +6963,8 @@
         </p:nvSpPr>
         <p:spPr>
           <a:xfrm>
-            <a:off x="777240" y="5669280"/>
-            <a:ext cx="10634472" cy="475488"/>
+            <a:off x="777240" y="5486400"/>
+            <a:ext cx="10634472" cy="457200"/>
           </a:xfrm>
           <a:prstGeom prst="rect">
             <a:avLst/>
@@ -6963,7 +7010,7 @@
         </p:nvSpPr>
         <p:spPr>
           <a:xfrm>
-            <a:off x="548640" y="6400800"/>
+            <a:off x="548640" y="6309360"/>
             <a:ext cx="5852160" cy="274320"/>
           </a:xfrm>
           <a:prstGeom prst="rect">
@@ -6973,7 +7020,7 @@
           <a:ln/>
         </p:spPr>
         <p:txBody>
-          <a:bodyPr wrap="square" lIns="0" tIns="0" rIns="0" bIns="0" rtlCol="0" anchor="t"/>
+          <a:bodyPr wrap="square" lIns="0" tIns="0" rIns="0" bIns="0" rtlCol="0" anchor="ctr"/>
           <a:lstStyle/>
           <a:p>
             <a:pPr indent="0" marL="0">
@@ -7003,7 +7050,7 @@
         </p:nvSpPr>
         <p:spPr>
           <a:xfrm>
-            <a:off x="11274552" y="6400800"/>
+            <a:off x="11274552" y="6309360"/>
             <a:ext cx="365760" cy="274320"/>
           </a:xfrm>
           <a:prstGeom prst="rect">
@@ -7016,7 +7063,7 @@
           </a:extLst>
         </p:spPr>
         <p:txBody>
-          <a:bodyPr/>
+          <a:bodyPr anchor="ctr"/>
           <a:lstStyle>
             <a:lvl1pPr>
               <a:defRPr sz="1000">
@@ -7072,7 +7119,7 @@
         <p:spPr>
           <a:xfrm>
             <a:off x="548640" y="384048"/>
-            <a:ext cx="7315200" cy="868680"/>
+            <a:ext cx="7040880" cy="868680"/>
           </a:xfrm>
           <a:prstGeom prst="rect">
             <a:avLst/>
@@ -7264,11 +7311,11 @@
         <p:spPr>
           <a:xfrm>
             <a:off x="548640" y="1600200"/>
-            <a:ext cx="7406640" cy="1417320"/>
+            <a:ext cx="7406640" cy="1508760"/>
           </a:xfrm>
           <a:prstGeom prst="roundRect">
             <a:avLst>
-              <a:gd name="adj" fmla="val 6452"/>
+              <a:gd name="adj" fmla="val 6061"/>
             </a:avLst>
           </a:prstGeom>
           <a:solidFill>
@@ -7393,8 +7440,8 @@
         </p:nvSpPr>
         <p:spPr>
           <a:xfrm>
-            <a:off x="3017520" y="1783080"/>
-            <a:ext cx="4754880" cy="1143000"/>
+            <a:off x="3017520" y="1801368"/>
+            <a:ext cx="4754880" cy="1216152"/>
           </a:xfrm>
           <a:prstGeom prst="rect">
             <a:avLst/>
@@ -7469,12 +7516,12 @@
         </p:nvSpPr>
         <p:spPr>
           <a:xfrm>
-            <a:off x="548640" y="3200400"/>
-            <a:ext cx="7406640" cy="1417320"/>
+            <a:off x="548640" y="3291840"/>
+            <a:ext cx="7406640" cy="1371600"/>
           </a:xfrm>
           <a:prstGeom prst="roundRect">
             <a:avLst>
-              <a:gd name="adj" fmla="val 6452"/>
+              <a:gd name="adj" fmla="val 6667"/>
             </a:avLst>
           </a:prstGeom>
           <a:solidFill>
@@ -7498,7 +7545,7 @@
         </p:nvSpPr>
         <p:spPr>
           <a:xfrm>
-            <a:off x="777240" y="3383280"/>
+            <a:off x="777240" y="3474720"/>
             <a:ext cx="1097280" cy="411480"/>
           </a:xfrm>
           <a:prstGeom prst="rect">
@@ -7534,7 +7581,7 @@
         </p:nvSpPr>
         <p:spPr>
           <a:xfrm>
-            <a:off x="777240" y="3803904"/>
+            <a:off x="777240" y="3895344"/>
             <a:ext cx="2103120" cy="320040"/>
           </a:xfrm>
           <a:prstGeom prst="rect">
@@ -7570,7 +7617,7 @@
         </p:nvSpPr>
         <p:spPr>
           <a:xfrm>
-            <a:off x="777240" y="4078224"/>
+            <a:off x="777240" y="4169664"/>
             <a:ext cx="2103120" cy="320040"/>
           </a:xfrm>
           <a:prstGeom prst="rect">
@@ -7606,8 +7653,8 @@
         </p:nvSpPr>
         <p:spPr>
           <a:xfrm>
-            <a:off x="3017520" y="3383280"/>
-            <a:ext cx="4754880" cy="1143000"/>
+            <a:off x="3017520" y="3493008"/>
+            <a:ext cx="4754880" cy="1078992"/>
           </a:xfrm>
           <a:prstGeom prst="rect">
             <a:avLst/>
@@ -7682,7 +7729,7 @@
         </p:nvSpPr>
         <p:spPr>
           <a:xfrm>
-            <a:off x="548640" y="4800600"/>
+            <a:off x="548640" y="4846320"/>
             <a:ext cx="7406640" cy="1188720"/>
           </a:xfrm>
           <a:prstGeom prst="roundRect">
@@ -7704,7 +7751,7 @@
         </p:nvSpPr>
         <p:spPr>
           <a:xfrm>
-            <a:off x="777240" y="4983480"/>
+            <a:off x="777240" y="5029200"/>
             <a:ext cx="1097280" cy="411480"/>
           </a:xfrm>
           <a:prstGeom prst="rect">
@@ -7740,7 +7787,7 @@
         </p:nvSpPr>
         <p:spPr>
           <a:xfrm>
-            <a:off x="777240" y="5404104"/>
+            <a:off x="777240" y="5449824"/>
             <a:ext cx="2103120" cy="320040"/>
           </a:xfrm>
           <a:prstGeom prst="rect">
@@ -7776,7 +7823,7 @@
         </p:nvSpPr>
         <p:spPr>
           <a:xfrm>
-            <a:off x="777240" y="5678424"/>
+            <a:off x="777240" y="5724144"/>
             <a:ext cx="2103120" cy="320040"/>
           </a:xfrm>
           <a:prstGeom prst="rect">
@@ -7812,17 +7859,17 @@
         </p:nvSpPr>
         <p:spPr>
           <a:xfrm>
-            <a:off x="3017520" y="4983480"/>
-            <a:ext cx="4754880" cy="914400"/>
-          </a:xfrm>
-          <a:prstGeom prst="rect">
-            <a:avLst/>
-          </a:prstGeom>
-          <a:noFill/>
-          <a:ln/>
-        </p:spPr>
-        <p:txBody>
-          <a:bodyPr wrap="square" lIns="0" tIns="0" rIns="0" bIns="0" rtlCol="0" anchor="ctr"/>
+            <a:off x="3017520" y="5047488"/>
+            <a:ext cx="4754880" cy="896112"/>
+          </a:xfrm>
+          <a:prstGeom prst="rect">
+            <a:avLst/>
+          </a:prstGeom>
+          <a:noFill/>
+          <a:ln/>
+        </p:spPr>
+        <p:txBody>
+          <a:bodyPr wrap="square" lIns="0" tIns="0" rIns="0" bIns="0" rtlCol="0" anchor="t"/>
           <a:lstStyle/>
           <a:p>
             <a:pPr marL="177800" indent="-177800">
@@ -7853,11 +7900,11 @@
         <p:spPr>
           <a:xfrm>
             <a:off x="8275320" y="1600200"/>
-            <a:ext cx="3364992" cy="1341120"/>
+            <a:ext cx="3364992" cy="1508760"/>
           </a:xfrm>
           <a:prstGeom prst="roundRect">
             <a:avLst>
-              <a:gd name="adj" fmla="val 6818"/>
+              <a:gd name="adj" fmla="val 6061"/>
             </a:avLst>
           </a:prstGeom>
           <a:solidFill>
@@ -7886,8 +7933,8 @@
         </p:nvSpPr>
         <p:spPr>
           <a:xfrm>
-            <a:off x="8503920" y="1764792"/>
-            <a:ext cx="2926080" cy="594360"/>
+            <a:off x="8503920" y="1737360"/>
+            <a:ext cx="2926080" cy="548640"/>
           </a:xfrm>
           <a:prstGeom prst="rect">
             <a:avLst/>
@@ -7903,14 +7950,14 @@
               <a:buNone/>
             </a:pPr>
             <a:r>
-              <a:rPr lang="en-US" sz="3400" b="1" dirty="0">
+              <a:rPr lang="en-US" sz="3200" b="1" dirty="0">
                 <a:solidFill>
                   <a:schemeClr val="accent1"/>
                 </a:solidFill>
               </a:rPr>
               <a:t>Weekly</a:t>
             </a:r>
-            <a:endParaRPr lang="en-US" sz="3400" dirty="0"/>
+            <a:endParaRPr lang="en-US" sz="3200" dirty="0"/>
           </a:p>
         </p:txBody>
       </p:sp>
@@ -7922,8 +7969,8 @@
         </p:nvSpPr>
         <p:spPr>
           <a:xfrm>
-            <a:off x="8503920" y="2377440"/>
-            <a:ext cx="2926080" cy="411480"/>
+            <a:off x="8503920" y="2295144"/>
+            <a:ext cx="2926080" cy="384048"/>
           </a:xfrm>
           <a:prstGeom prst="rect">
             <a:avLst/>
@@ -7958,12 +8005,12 @@
         </p:nvSpPr>
         <p:spPr>
           <a:xfrm>
-            <a:off x="8275320" y="3124200"/>
-            <a:ext cx="3364992" cy="1341120"/>
+            <a:off x="8275320" y="3291840"/>
+            <a:ext cx="3364992" cy="1371600"/>
           </a:xfrm>
           <a:prstGeom prst="roundRect">
             <a:avLst>
-              <a:gd name="adj" fmla="val 6818"/>
+              <a:gd name="adj" fmla="val 6667"/>
             </a:avLst>
           </a:prstGeom>
           <a:solidFill>
@@ -7992,8 +8039,8 @@
         </p:nvSpPr>
         <p:spPr>
           <a:xfrm>
-            <a:off x="8503920" y="3288792"/>
-            <a:ext cx="2926080" cy="594360"/>
+            <a:off x="8503920" y="3429000"/>
+            <a:ext cx="2926080" cy="548640"/>
           </a:xfrm>
           <a:prstGeom prst="rect">
             <a:avLst/>
@@ -8009,14 +8056,14 @@
               <a:buNone/>
             </a:pPr>
             <a:r>
-              <a:rPr lang="en-US" sz="3400" b="1" dirty="0">
+              <a:rPr lang="en-US" sz="3200" b="1" dirty="0">
                 <a:solidFill>
                   <a:schemeClr val="accent2"/>
                 </a:solidFill>
               </a:rPr>
               <a:t>2 hours</a:t>
             </a:r>
-            <a:endParaRPr lang="en-US" sz="3400" dirty="0"/>
+            <a:endParaRPr lang="en-US" sz="3200" dirty="0"/>
           </a:p>
         </p:txBody>
       </p:sp>
@@ -8028,8 +8075,8 @@
         </p:nvSpPr>
         <p:spPr>
           <a:xfrm>
-            <a:off x="8503920" y="3901440"/>
-            <a:ext cx="2926080" cy="411480"/>
+            <a:off x="8503920" y="3986784"/>
+            <a:ext cx="2926080" cy="384048"/>
           </a:xfrm>
           <a:prstGeom prst="rect">
             <a:avLst/>
@@ -8064,12 +8111,12 @@
         </p:nvSpPr>
         <p:spPr>
           <a:xfrm>
-            <a:off x="8275320" y="4648200"/>
-            <a:ext cx="3364992" cy="1341120"/>
+            <a:off x="8275320" y="4846320"/>
+            <a:ext cx="3364992" cy="1188720"/>
           </a:xfrm>
           <a:prstGeom prst="roundRect">
             <a:avLst>
-              <a:gd name="adj" fmla="val 6818"/>
+              <a:gd name="adj" fmla="val 7692"/>
             </a:avLst>
           </a:prstGeom>
           <a:solidFill>
@@ -8098,8 +8145,8 @@
         </p:nvSpPr>
         <p:spPr>
           <a:xfrm>
-            <a:off x="8503920" y="4812792"/>
-            <a:ext cx="2926080" cy="594360"/>
+            <a:off x="8503920" y="4983480"/>
+            <a:ext cx="2926080" cy="548640"/>
           </a:xfrm>
           <a:prstGeom prst="rect">
             <a:avLst/>
@@ -8115,14 +8162,14 @@
               <a:buNone/>
             </a:pPr>
             <a:r>
-              <a:rPr lang="en-US" sz="3400" b="1" dirty="0">
+              <a:rPr lang="en-US" sz="3200" b="1" dirty="0">
                 <a:solidFill>
                   <a:schemeClr val="accent2"/>
                 </a:solidFill>
               </a:rPr>
               <a:t>1 hour</a:t>
             </a:r>
-            <a:endParaRPr lang="en-US" sz="3400" dirty="0"/>
+            <a:endParaRPr lang="en-US" sz="3200" dirty="0"/>
           </a:p>
         </p:txBody>
       </p:sp>
@@ -8134,8 +8181,8 @@
         </p:nvSpPr>
         <p:spPr>
           <a:xfrm>
-            <a:off x="8503920" y="5425440"/>
-            <a:ext cx="2926080" cy="411480"/>
+            <a:off x="8503920" y="5541264"/>
+            <a:ext cx="2926080" cy="384048"/>
           </a:xfrm>
           <a:prstGeom prst="rect">
             <a:avLst/>
@@ -8170,7 +8217,7 @@
         </p:nvSpPr>
         <p:spPr>
           <a:xfrm>
-            <a:off x="548640" y="6400800"/>
+            <a:off x="548640" y="6309360"/>
             <a:ext cx="5852160" cy="274320"/>
           </a:xfrm>
           <a:prstGeom prst="rect">
@@ -8180,7 +8227,7 @@
           <a:ln/>
         </p:spPr>
         <p:txBody>
-          <a:bodyPr wrap="square" lIns="0" tIns="0" rIns="0" bIns="0" rtlCol="0" anchor="t"/>
+          <a:bodyPr wrap="square" lIns="0" tIns="0" rIns="0" bIns="0" rtlCol="0" anchor="ctr"/>
           <a:lstStyle/>
           <a:p>
             <a:pPr indent="0" marL="0">
@@ -8210,7 +8257,7 @@
         </p:nvSpPr>
         <p:spPr>
           <a:xfrm>
-            <a:off x="11274552" y="6400800"/>
+            <a:off x="11274552" y="6309360"/>
             <a:ext cx="365760" cy="274320"/>
           </a:xfrm>
           <a:prstGeom prst="rect">
@@ -8223,7 +8270,7 @@
           </a:extLst>
         </p:spPr>
         <p:txBody>
-          <a:bodyPr/>
+          <a:bodyPr anchor="ctr"/>
           <a:lstStyle>
             <a:lvl1pPr>
               <a:defRPr sz="1000">
@@ -8279,7 +8326,7 @@
         <p:spPr>
           <a:xfrm>
             <a:off x="548640" y="384048"/>
-            <a:ext cx="7315200" cy="868680"/>
+            <a:ext cx="7040880" cy="868680"/>
           </a:xfrm>
           <a:prstGeom prst="rect">
             <a:avLst/>
@@ -8318,11 +8365,11 @@
         <p:spPr>
           <a:xfrm>
             <a:off x="548640" y="1600200"/>
-            <a:ext cx="5449824" cy="2103120"/>
+            <a:ext cx="5408676" cy="2011680"/>
           </a:xfrm>
           <a:prstGeom prst="roundRect">
             <a:avLst>
-              <a:gd name="adj" fmla="val 4348"/>
+              <a:gd name="adj" fmla="val 4545"/>
             </a:avLst>
           </a:prstGeom>
           <a:solidFill>
@@ -8398,7 +8445,7 @@
         <p:spPr>
           <a:xfrm>
             <a:off x="1737360" y="1947672"/>
-            <a:ext cx="3986784" cy="594360"/>
+            <a:ext cx="3945636" cy="594360"/>
           </a:xfrm>
           <a:prstGeom prst="rect">
             <a:avLst/>
@@ -8434,7 +8481,7 @@
         <p:spPr>
           <a:xfrm>
             <a:off x="1737360" y="2587752"/>
-            <a:ext cx="3986784" cy="960120"/>
+            <a:ext cx="3945636" cy="960120"/>
           </a:xfrm>
           <a:prstGeom prst="rect">
             <a:avLst/>
@@ -8469,12 +8516,12 @@
         </p:nvSpPr>
         <p:spPr>
           <a:xfrm>
-            <a:off x="6190488" y="1600200"/>
-            <a:ext cx="5449824" cy="2103120"/>
+            <a:off x="6231636" y="1600200"/>
+            <a:ext cx="5408676" cy="2011680"/>
           </a:xfrm>
           <a:prstGeom prst="roundRect">
             <a:avLst>
-              <a:gd name="adj" fmla="val 4348"/>
+              <a:gd name="adj" fmla="val 4545"/>
             </a:avLst>
           </a:prstGeom>
           <a:solidFill>
@@ -8503,7 +8550,7 @@
         </p:nvSpPr>
         <p:spPr>
           <a:xfrm>
-            <a:off x="6510528" y="1920240"/>
+            <a:off x="6551676" y="1920240"/>
             <a:ext cx="658368" cy="658368"/>
           </a:xfrm>
           <a:prstGeom prst="ellipse">
@@ -8533,7 +8580,7 @@
         </p:blipFill>
         <p:spPr>
           <a:xfrm>
-            <a:off x="6675120" y="2084832"/>
+            <a:off x="6716268" y="2084832"/>
             <a:ext cx="329184" cy="329184"/>
           </a:xfrm>
           <a:prstGeom prst="rect">
@@ -8549,8 +8596,8 @@
         </p:nvSpPr>
         <p:spPr>
           <a:xfrm>
-            <a:off x="7379208" y="1947672"/>
-            <a:ext cx="3986784" cy="594360"/>
+            <a:off x="7420356" y="1947672"/>
+            <a:ext cx="3945636" cy="594360"/>
           </a:xfrm>
           <a:prstGeom prst="rect">
             <a:avLst/>
@@ -8585,8 +8632,8 @@
         </p:nvSpPr>
         <p:spPr>
           <a:xfrm>
-            <a:off x="7379208" y="2587752"/>
-            <a:ext cx="3986784" cy="960120"/>
+            <a:off x="7420356" y="2587752"/>
+            <a:ext cx="3945636" cy="960120"/>
           </a:xfrm>
           <a:prstGeom prst="rect">
             <a:avLst/>
@@ -8622,11 +8669,11 @@
         <p:spPr>
           <a:xfrm>
             <a:off x="548640" y="3886200"/>
-            <a:ext cx="5449824" cy="2103120"/>
+            <a:ext cx="5408676" cy="2011680"/>
           </a:xfrm>
           <a:prstGeom prst="roundRect">
             <a:avLst>
-              <a:gd name="adj" fmla="val 4348"/>
+              <a:gd name="adj" fmla="val 4545"/>
             </a:avLst>
           </a:prstGeom>
           <a:solidFill>
@@ -8702,7 +8749,7 @@
         <p:spPr>
           <a:xfrm>
             <a:off x="1737360" y="4233672"/>
-            <a:ext cx="3986784" cy="594360"/>
+            <a:ext cx="3945636" cy="594360"/>
           </a:xfrm>
           <a:prstGeom prst="rect">
             <a:avLst/>
@@ -8738,7 +8785,7 @@
         <p:spPr>
           <a:xfrm>
             <a:off x="1737360" y="4873752"/>
-            <a:ext cx="3986784" cy="960120"/>
+            <a:ext cx="3945636" cy="960120"/>
           </a:xfrm>
           <a:prstGeom prst="rect">
             <a:avLst/>
@@ -8773,12 +8820,12 @@
         </p:nvSpPr>
         <p:spPr>
           <a:xfrm>
-            <a:off x="6190488" y="3886200"/>
-            <a:ext cx="5449824" cy="2103120"/>
+            <a:off x="6231636" y="3886200"/>
+            <a:ext cx="5408676" cy="2011680"/>
           </a:xfrm>
           <a:prstGeom prst="roundRect">
             <a:avLst>
-              <a:gd name="adj" fmla="val 4348"/>
+              <a:gd name="adj" fmla="val 4545"/>
             </a:avLst>
           </a:prstGeom>
           <a:solidFill>
@@ -8807,7 +8854,7 @@
         </p:nvSpPr>
         <p:spPr>
           <a:xfrm>
-            <a:off x="6510528" y="4206240"/>
+            <a:off x="6551676" y="4206240"/>
             <a:ext cx="658368" cy="658368"/>
           </a:xfrm>
           <a:prstGeom prst="ellipse">
@@ -8837,7 +8884,7 @@
         </p:blipFill>
         <p:spPr>
           <a:xfrm>
-            <a:off x="6675120" y="4370832"/>
+            <a:off x="6716268" y="4370832"/>
             <a:ext cx="329184" cy="329184"/>
           </a:xfrm>
           <a:prstGeom prst="rect">
@@ -8853,8 +8900,8 @@
         </p:nvSpPr>
         <p:spPr>
           <a:xfrm>
-            <a:off x="7379208" y="4233672"/>
-            <a:ext cx="3986784" cy="594360"/>
+            <a:off x="7420356" y="4233672"/>
+            <a:ext cx="3945636" cy="594360"/>
           </a:xfrm>
           <a:prstGeom prst="rect">
             <a:avLst/>
@@ -8889,8 +8936,8 @@
         </p:nvSpPr>
         <p:spPr>
           <a:xfrm>
-            <a:off x="7379208" y="4873752"/>
-            <a:ext cx="3986784" cy="960120"/>
+            <a:off x="7420356" y="4873752"/>
+            <a:ext cx="3945636" cy="960120"/>
           </a:xfrm>
           <a:prstGeom prst="rect">
             <a:avLst/>
@@ -8925,7 +8972,7 @@
         </p:nvSpPr>
         <p:spPr>
           <a:xfrm>
-            <a:off x="548640" y="6400800"/>
+            <a:off x="548640" y="6309360"/>
             <a:ext cx="5852160" cy="274320"/>
           </a:xfrm>
           <a:prstGeom prst="rect">
@@ -8935,7 +8982,7 @@
           <a:ln/>
         </p:spPr>
         <p:txBody>
-          <a:bodyPr wrap="square" lIns="0" tIns="0" rIns="0" bIns="0" rtlCol="0" anchor="t"/>
+          <a:bodyPr wrap="square" lIns="0" tIns="0" rIns="0" bIns="0" rtlCol="0" anchor="ctr"/>
           <a:lstStyle/>
           <a:p>
             <a:pPr indent="0" marL="0">
@@ -8965,7 +9012,7 @@
         </p:nvSpPr>
         <p:spPr>
           <a:xfrm>
-            <a:off x="11274552" y="6400800"/>
+            <a:off x="11274552" y="6309360"/>
             <a:ext cx="365760" cy="274320"/>
           </a:xfrm>
           <a:prstGeom prst="rect">
@@ -8978,7 +9025,7 @@
           </a:extLst>
         </p:spPr>
         <p:txBody>
-          <a:bodyPr/>
+          <a:bodyPr anchor="ctr"/>
           <a:lstStyle>
             <a:lvl1pPr>
               <a:defRPr sz="1000">
@@ -9034,7 +9081,7 @@
         <p:spPr>
           <a:xfrm>
             <a:off x="548640" y="548640"/>
-            <a:ext cx="7315200" cy="868680"/>
+            <a:ext cx="7040880" cy="868680"/>
           </a:xfrm>
           <a:prstGeom prst="rect">
             <a:avLst/>
@@ -9109,7 +9156,7 @@
         <p:spPr>
           <a:xfrm>
             <a:off x="548640" y="3154680"/>
-            <a:ext cx="3291840" cy="0"/>
+            <a:ext cx="3575304" cy="0"/>
           </a:xfrm>
           <a:prstGeom prst="line">
             <a:avLst/>
@@ -9169,7 +9216,7 @@
         <p:spPr>
           <a:xfrm>
             <a:off x="548640" y="3886200"/>
-            <a:ext cx="3291840" cy="1280160"/>
+            <a:ext cx="3474720" cy="1280160"/>
           </a:xfrm>
           <a:prstGeom prst="rect">
             <a:avLst/>
@@ -9241,7 +9288,7 @@
         <p:spPr>
           <a:xfrm>
             <a:off x="4306824" y="3154680"/>
-            <a:ext cx="3291840" cy="0"/>
+            <a:ext cx="3575304" cy="0"/>
           </a:xfrm>
           <a:prstGeom prst="line">
             <a:avLst/>
@@ -9301,7 +9348,7 @@
         <p:spPr>
           <a:xfrm>
             <a:off x="4306824" y="3886200"/>
-            <a:ext cx="3291840" cy="1280160"/>
+            <a:ext cx="3474720" cy="1280160"/>
           </a:xfrm>
           <a:prstGeom prst="rect">
             <a:avLst/>
@@ -9373,7 +9420,7 @@
         <p:spPr>
           <a:xfrm>
             <a:off x="8065008" y="3154680"/>
-            <a:ext cx="3291840" cy="0"/>
+            <a:ext cx="3575304" cy="0"/>
           </a:xfrm>
           <a:prstGeom prst="line">
             <a:avLst/>
@@ -9433,7 +9480,7 @@
         <p:spPr>
           <a:xfrm>
             <a:off x="8065008" y="3886200"/>
-            <a:ext cx="3291840" cy="1280160"/>
+            <a:ext cx="3474720" cy="1280160"/>
           </a:xfrm>
           <a:prstGeom prst="rect">
             <a:avLst/>
@@ -9468,7 +9515,7 @@
         </p:nvSpPr>
         <p:spPr>
           <a:xfrm>
-            <a:off x="548640" y="6400800"/>
+            <a:off x="548640" y="6309360"/>
             <a:ext cx="5852160" cy="274320"/>
           </a:xfrm>
           <a:prstGeom prst="rect">
@@ -9478,7 +9525,7 @@
           <a:ln/>
         </p:spPr>
         <p:txBody>
-          <a:bodyPr wrap="square" lIns="0" tIns="0" rIns="0" bIns="0" rtlCol="0" anchor="t"/>
+          <a:bodyPr wrap="square" lIns="0" tIns="0" rIns="0" bIns="0" rtlCol="0" anchor="ctr"/>
           <a:lstStyle/>
           <a:p>
             <a:pPr indent="0" marL="0">
@@ -9508,7 +9555,7 @@
         </p:nvSpPr>
         <p:spPr>
           <a:xfrm>
-            <a:off x="11274552" y="6400800"/>
+            <a:off x="11274552" y="6309360"/>
             <a:ext cx="365760" cy="274320"/>
           </a:xfrm>
           <a:prstGeom prst="rect">
@@ -9521,7 +9568,7 @@
           </a:extLst>
         </p:spPr>
         <p:txBody>
-          <a:bodyPr/>
+          <a:bodyPr anchor="ctr"/>
           <a:lstStyle>
             <a:lvl1pPr>
               <a:defRPr sz="1000">
@@ -9566,50 +9613,9 @@
           <a:chExt cx="0" cy="0"/>
         </a:xfrm>
       </p:grpSpPr>
-      <p:sp>
-        <p:nvSpPr>
-          <p:cNvPr id="2" name="Text 1"/>
-          <p:cNvSpPr/>
-          <p:nvPr>
-            <p:ph idx="101" type="title" hasCustomPrompt="1"/>
-          </p:nvPr>
-        </p:nvSpPr>
-        <p:spPr>
-          <a:xfrm>
-            <a:off x="548640" y="384048"/>
-            <a:ext cx="7315200" cy="868680"/>
-          </a:xfrm>
-          <a:prstGeom prst="rect">
-            <a:avLst/>
-          </a:prstGeom>
-          <a:noFill/>
-          <a:ln/>
-        </p:spPr>
-        <p:txBody>
-          <a:bodyPr wrap="square" lIns="0" tIns="0" rIns="0" bIns="0" rtlCol="0" anchor="t"/>
-          <a:lstStyle/>
-          <a:p>
-            <a:pPr algn="l" indent="0" marL="0">
-              <a:buNone/>
-            </a:pPr>
-            <a:r>
-              <a:rPr lang="en-US" sz="2800" b="1" dirty="0">
-                <a:solidFill>
-                  <a:schemeClr val="tx1"/>
-                </a:solidFill>
-                <a:latin typeface="Arial" pitchFamily="34" charset="0"/>
-                <a:ea typeface="Arial" pitchFamily="34" charset="-122"/>
-                <a:cs typeface="Arial" pitchFamily="34" charset="-120"/>
-              </a:rPr>
-              <a:t>Appendix: the whole process on one page</a:t>
-            </a:r>
-            <a:endParaRPr lang="en-US" sz="2800" dirty="0"/>
-          </a:p>
-        </p:txBody>
-      </p:sp>
       <p:pic>
         <p:nvPicPr>
-          <p:cNvPr id="3" name="handout" descr="One-page process flow of sanctioned bank BIN blocking">    </p:cNvPr>
+          <p:cNvPr id="2" name="handout" descr="Appendix: one-page process flow of sanctioned bank BIN blocking">    </p:cNvPr>
           <p:cNvPicPr>
             <a:picLocks noChangeAspect="1"/>
           </p:cNvPicPr>
@@ -9623,95 +9629,14 @@
         </p:blipFill>
         <p:spPr>
           <a:xfrm>
-            <a:off x="1569568" y="1143000"/>
-            <a:ext cx="9052560" cy="5092065"/>
+            <a:off x="0" y="0"/>
+            <a:ext cx="12191695" cy="6858000"/>
           </a:xfrm>
           <a:prstGeom prst="rect">
             <a:avLst/>
           </a:prstGeom>
         </p:spPr>
       </p:pic>
-      <p:sp>
-        <p:nvSpPr>
-          <p:cNvPr id="4" name="Text 1"/>
-          <p:cNvSpPr txBox="1"/>
-          <p:nvPr/>
-        </p:nvSpPr>
-        <p:spPr>
-          <a:xfrm>
-            <a:off x="548640" y="6400800"/>
-            <a:ext cx="5852160" cy="274320"/>
-          </a:xfrm>
-          <a:prstGeom prst="rect">
-            <a:avLst/>
-          </a:prstGeom>
-          <a:noFill/>
-          <a:ln/>
-        </p:spPr>
-        <p:txBody>
-          <a:bodyPr wrap="square" lIns="0" tIns="0" rIns="0" bIns="0" rtlCol="0" anchor="t"/>
-          <a:lstStyle/>
-          <a:p>
-            <a:pPr indent="0" marL="0">
-              <a:buNone/>
-            </a:pPr>
-            <a:r>
-              <a:rPr lang="en-US" sz="1000" dirty="0">
-                <a:solidFill>
-                  <a:schemeClr val="tx2"/>
-                </a:solidFill>
-              </a:rPr>
-              <a:t>Source: Blocking framework §4, §6 to §11. Print the PDF version as a handout.</a:t>
-            </a:r>
-            <a:endParaRPr lang="en-US" sz="1000" dirty="0"/>
-          </a:p>
-        </p:txBody>
-      </p:sp>
-      <p:sp>
-        <p:nvSpPr>
-          <p:cNvPr id="25" name="Slide Number Placeholder 0"/>
-          <p:cNvSpPr>
-            <a:spLocks noGrp="1"/>
-          </p:cNvSpPr>
-          <p:nvPr>
-            <p:ph type="sldNum" sz="quarter" idx="4294967295"/>
-          </p:nvPr>
-        </p:nvSpPr>
-        <p:spPr>
-          <a:xfrm>
-            <a:off x="11274552" y="6400800"/>
-            <a:ext cx="365760" cy="274320"/>
-          </a:xfrm>
-          <a:prstGeom prst="rect">
-            <a:avLst/>
-          </a:prstGeom>
-          <a:extLst>
-            <a:ext uri="{C572A759-6A51-4108-AA02-DFA0A04FC94B}">
-              <ma14:wrappingTextBoxFlag xmlns:ma14="http://schemas.microsoft.com/office/mac/drawingml/2011/main" val="0"/>
-            </a:ext>
-          </a:extLst>
-        </p:spPr>
-        <p:txBody>
-          <a:bodyPr/>
-          <a:lstStyle>
-            <a:lvl1pPr>
-              <a:defRPr sz="1000">
-                <a:solidFill>
-                  <a:schemeClr val="tx2"/>
-                </a:solidFill>
-              </a:defRPr>
-            </a:lvl1pPr>
-          </a:lstStyle>
-          <a:p>
-            <a:pPr algn="r"/>
-            <a:fld id="{F7021451-1387-4CA6-816F-3879F97B5CBC}" type="slidenum">
-              <a:rPr b="0" lang="en-US"/>
-              <a:t>8</a:t>
-            </a:fld>
-            <a:endParaRPr lang="en-US"/>
-          </a:p>
-        </p:txBody>
-      </p:sp>
     </p:spTree>
   </p:cSld>
   <p:clrMapOvr>

</xml_diff>